<commit_message>
Added powerpoint for meeting 05 and related images to designated meeting_05 folder
</commit_message>
<xml_diff>
--- a/dev_documents/meetings/meeting_04/meeting-04.pptx
+++ b/dev_documents/meetings/meeting_04/meeting-04.pptx
@@ -124,6 +124,11 @@
       </a:defRPr>
     </a:lvl9pPr>
   </p:defaultTextStyle>
+  <p:extLst>
+    <p:ext uri="{EFAFB233-063F-42B5-8137-9DF3F51BA10A}">
+      <p15:sldGuideLst xmlns:p15="http://schemas.microsoft.com/office/powerpoint/2012/main"/>
+    </p:ext>
+  </p:extLst>
 </p:presentation>
 </file>
 
@@ -276,7 +281,7 @@
           <a:p>
             <a:fld id="{230C4F87-138F-4E6A-9A5A-C65F56B5351E}" type="datetimeFigureOut">
               <a:rPr lang="de-CH" smtClean="0"/>
-              <a:t>06.11.2025</a:t>
+              <a:t>20.11.2025</a:t>
             </a:fld>
             <a:endParaRPr lang="de-CH"/>
           </a:p>
@@ -476,7 +481,7 @@
           <a:p>
             <a:fld id="{230C4F87-138F-4E6A-9A5A-C65F56B5351E}" type="datetimeFigureOut">
               <a:rPr lang="de-CH" smtClean="0"/>
-              <a:t>06.11.2025</a:t>
+              <a:t>20.11.2025</a:t>
             </a:fld>
             <a:endParaRPr lang="de-CH"/>
           </a:p>
@@ -686,7 +691,7 @@
           <a:p>
             <a:fld id="{230C4F87-138F-4E6A-9A5A-C65F56B5351E}" type="datetimeFigureOut">
               <a:rPr lang="de-CH" smtClean="0"/>
-              <a:t>06.11.2025</a:t>
+              <a:t>20.11.2025</a:t>
             </a:fld>
             <a:endParaRPr lang="de-CH"/>
           </a:p>
@@ -886,7 +891,7 @@
           <a:p>
             <a:fld id="{230C4F87-138F-4E6A-9A5A-C65F56B5351E}" type="datetimeFigureOut">
               <a:rPr lang="de-CH" smtClean="0"/>
-              <a:t>06.11.2025</a:t>
+              <a:t>20.11.2025</a:t>
             </a:fld>
             <a:endParaRPr lang="de-CH"/>
           </a:p>
@@ -1162,7 +1167,7 @@
           <a:p>
             <a:fld id="{230C4F87-138F-4E6A-9A5A-C65F56B5351E}" type="datetimeFigureOut">
               <a:rPr lang="de-CH" smtClean="0"/>
-              <a:t>06.11.2025</a:t>
+              <a:t>20.11.2025</a:t>
             </a:fld>
             <a:endParaRPr lang="de-CH"/>
           </a:p>
@@ -1430,7 +1435,7 @@
           <a:p>
             <a:fld id="{230C4F87-138F-4E6A-9A5A-C65F56B5351E}" type="datetimeFigureOut">
               <a:rPr lang="de-CH" smtClean="0"/>
-              <a:t>06.11.2025</a:t>
+              <a:t>20.11.2025</a:t>
             </a:fld>
             <a:endParaRPr lang="de-CH"/>
           </a:p>
@@ -1845,7 +1850,7 @@
           <a:p>
             <a:fld id="{230C4F87-138F-4E6A-9A5A-C65F56B5351E}" type="datetimeFigureOut">
               <a:rPr lang="de-CH" smtClean="0"/>
-              <a:t>06.11.2025</a:t>
+              <a:t>20.11.2025</a:t>
             </a:fld>
             <a:endParaRPr lang="de-CH"/>
           </a:p>
@@ -1987,7 +1992,7 @@
           <a:p>
             <a:fld id="{230C4F87-138F-4E6A-9A5A-C65F56B5351E}" type="datetimeFigureOut">
               <a:rPr lang="de-CH" smtClean="0"/>
-              <a:t>06.11.2025</a:t>
+              <a:t>20.11.2025</a:t>
             </a:fld>
             <a:endParaRPr lang="de-CH"/>
           </a:p>
@@ -2100,7 +2105,7 @@
           <a:p>
             <a:fld id="{230C4F87-138F-4E6A-9A5A-C65F56B5351E}" type="datetimeFigureOut">
               <a:rPr lang="de-CH" smtClean="0"/>
-              <a:t>06.11.2025</a:t>
+              <a:t>20.11.2025</a:t>
             </a:fld>
             <a:endParaRPr lang="de-CH"/>
           </a:p>
@@ -2413,7 +2418,7 @@
           <a:p>
             <a:fld id="{230C4F87-138F-4E6A-9A5A-C65F56B5351E}" type="datetimeFigureOut">
               <a:rPr lang="de-CH" smtClean="0"/>
-              <a:t>06.11.2025</a:t>
+              <a:t>20.11.2025</a:t>
             </a:fld>
             <a:endParaRPr lang="de-CH"/>
           </a:p>
@@ -2702,7 +2707,7 @@
           <a:p>
             <a:fld id="{230C4F87-138F-4E6A-9A5A-C65F56B5351E}" type="datetimeFigureOut">
               <a:rPr lang="de-CH" smtClean="0"/>
-              <a:t>06.11.2025</a:t>
+              <a:t>20.11.2025</a:t>
             </a:fld>
             <a:endParaRPr lang="de-CH"/>
           </a:p>
@@ -2945,7 +2950,7 @@
           <a:p>
             <a:fld id="{230C4F87-138F-4E6A-9A5A-C65F56B5351E}" type="datetimeFigureOut">
               <a:rPr lang="de-CH" smtClean="0"/>
-              <a:t>06.11.2025</a:t>
+              <a:t>20.11.2025</a:t>
             </a:fld>
             <a:endParaRPr lang="de-CH"/>
           </a:p>

</xml_diff>